<commit_message>
style: change all text color to black for full visibility
</commit_message>
<xml_diff>
--- a/SIH_Final_PPT.pptx
+++ b/SIH_Final_PPT.pptx
@@ -5552,7 +5552,7 @@
             <a:r>
               <a:rPr sz="2400" b="1">
                 <a:solidFill>
-                  <a:srgbClr val="FFFFFF"/>
+                  <a:srgbClr val="000000"/>
                 </a:solidFill>
                 <a:latin typeface="Garamond"/>
               </a:rPr>
@@ -5592,7 +5592,7 @@
             <a:r>
               <a:rPr lang="en-US" sz="4000" b="1" dirty="0">
                 <a:solidFill>
-                  <a:schemeClr val="tx2"/>
+                  <a:srgbClr val="000000"/>
                 </a:solidFill>
                 <a:latin typeface="Garamond" panose="02020404030301010803" pitchFamily="18" charset="0"/>
               </a:rPr>
@@ -5601,7 +5601,7 @@
             <a:r>
               <a:rPr lang="en-US" sz="4000" b="1" dirty="0" smtClean="0">
                 <a:solidFill>
-                  <a:schemeClr val="tx2"/>
+                  <a:srgbClr val="000000"/>
                 </a:solidFill>
                 <a:latin typeface="Garamond" panose="02020404030301010803" pitchFamily="18" charset="0"/>
               </a:rPr>
@@ -5646,7 +5646,7 @@
             <a:r>
               <a:rPr sz="1200" b="1">
                 <a:solidFill>
-                  <a:srgbClr val="FFFFFF"/>
+                  <a:srgbClr val="000000"/>
                 </a:solidFill>
                 <a:latin typeface="Arial"/>
               </a:rPr>
@@ -5655,7 +5655,7 @@
             <a:r>
               <a:rPr sz="1250" b="1">
                 <a:solidFill>
-                  <a:srgbClr val="FFFFFF"/>
+                  <a:srgbClr val="000000"/>
                 </a:solidFill>
                 <a:latin typeface="Arial"/>
               </a:rPr>
@@ -5672,7 +5672,7 @@
             <a:r>
               <a:rPr sz="1200" b="1">
                 <a:solidFill>
-                  <a:srgbClr val="FFFFFF"/>
+                  <a:srgbClr val="000000"/>
                 </a:solidFill>
                 <a:latin typeface="Arial"/>
               </a:rPr>
@@ -5681,7 +5681,7 @@
             <a:r>
               <a:rPr sz="1250" b="1">
                 <a:solidFill>
-                  <a:srgbClr val="FFFFFF"/>
+                  <a:srgbClr val="000000"/>
                 </a:solidFill>
                 <a:latin typeface="Arial"/>
               </a:rPr>
@@ -5697,7 +5697,7 @@
             <a:r>
               <a:rPr sz="1200" b="1">
                 <a:solidFill>
-                  <a:srgbClr val="FFFFFF"/>
+                  <a:srgbClr val="000000"/>
                 </a:solidFill>
                 <a:latin typeface="Arial"/>
               </a:rPr>
@@ -5706,7 +5706,7 @@
             <a:r>
               <a:rPr sz="1250" b="1">
                 <a:solidFill>
-                  <a:srgbClr val="FFFFFF"/>
+                  <a:srgbClr val="000000"/>
                 </a:solidFill>
                 <a:latin typeface="Arial"/>
               </a:rPr>
@@ -5722,7 +5722,7 @@
             <a:r>
               <a:rPr sz="1200" b="1">
                 <a:solidFill>
-                  <a:srgbClr val="FFFFFF"/>
+                  <a:srgbClr val="000000"/>
                 </a:solidFill>
                 <a:latin typeface="Arial"/>
               </a:rPr>
@@ -5731,7 +5731,7 @@
             <a:r>
               <a:rPr sz="1250" b="1">
                 <a:solidFill>
-                  <a:srgbClr val="FFFFFF"/>
+                  <a:srgbClr val="000000"/>
                 </a:solidFill>
                 <a:latin typeface="Arial"/>
               </a:rPr>
@@ -5747,7 +5747,7 @@
             <a:r>
               <a:rPr sz="1200" b="1">
                 <a:solidFill>
-                  <a:srgbClr val="FFFFFF"/>
+                  <a:srgbClr val="000000"/>
                 </a:solidFill>
                 <a:latin typeface="Arial"/>
               </a:rPr>
@@ -5756,7 +5756,7 @@
             <a:r>
               <a:rPr sz="1250" b="1">
                 <a:solidFill>
-                  <a:srgbClr val="FFFFFF"/>
+                  <a:srgbClr val="000000"/>
                 </a:solidFill>
                 <a:latin typeface="Arial"/>
               </a:rPr>
@@ -5772,7 +5772,7 @@
             <a:r>
               <a:rPr sz="1200" b="1">
                 <a:solidFill>
-                  <a:srgbClr val="FFFFFF"/>
+                  <a:srgbClr val="000000"/>
                 </a:solidFill>
                 <a:latin typeface="Arial"/>
               </a:rPr>
@@ -5781,7 +5781,7 @@
             <a:r>
               <a:rPr sz="1250" b="1">
                 <a:solidFill>
-                  <a:srgbClr val="FFFFFF"/>
+                  <a:srgbClr val="000000"/>
                 </a:solidFill>
                 <a:latin typeface="Arial"/>
               </a:rPr>
@@ -5865,7 +5865,7 @@
             <a:r>
               <a:rPr sz="1250" b="1">
                 <a:solidFill>
-                  <a:srgbClr val="FFFFFF"/>
+                  <a:srgbClr val="000000"/>
                 </a:solidFill>
                 <a:latin typeface="Arial"/>
               </a:rPr>
@@ -5919,7 +5919,7 @@
             <a:r>
               <a:rPr sz="1250" b="1">
                 <a:solidFill>
-                  <a:srgbClr val="FFFFFF"/>
+                  <a:srgbClr val="000000"/>
                 </a:solidFill>
                 <a:latin typeface="Arial"/>
               </a:rPr>
@@ -5954,7 +5954,7 @@
             <a:r>
               <a:rPr sz="1150" b="1">
                 <a:solidFill>
-                  <a:srgbClr val="FFFFFF"/>
+                  <a:srgbClr val="000000"/>
                 </a:solidFill>
                 <a:latin typeface="Arial"/>
               </a:rPr>
@@ -6046,7 +6046,7 @@
             <a:r>
               <a:rPr lang="en-US">
                 <a:solidFill>
-                  <a:schemeClr val="bg1"/>
+                  <a:srgbClr val="000000"/>
                 </a:solidFill>
               </a:rPr>
               <a:t>@SIH Idea submission- Template</a:t>
@@ -6115,7 +6115,7 @@
             <a:r>
               <a:rPr sz="2300" b="1">
                 <a:solidFill>
-                  <a:srgbClr val="FFFFFF"/>
+                  <a:srgbClr val="000000"/>
                 </a:solidFill>
                 <a:latin typeface="Arial"/>
               </a:rPr>
@@ -6150,7 +6150,7 @@
             <a:r>
               <a:rPr sz="1500" b="1">
                 <a:solidFill>
-                  <a:srgbClr val="FFFFFF"/>
+                  <a:srgbClr val="000000"/>
                 </a:solidFill>
                 <a:latin typeface="Arial"/>
               </a:rPr>
@@ -6185,7 +6185,7 @@
             <a:r>
               <a:rPr sz="1250" b="1">
                 <a:solidFill>
-                  <a:srgbClr val="FFFFFF"/>
+                  <a:srgbClr val="000000"/>
                 </a:solidFill>
                 <a:latin typeface="Arial"/>
               </a:rPr>
@@ -6239,7 +6239,7 @@
             <a:r>
               <a:rPr sz="1200" b="1">
                 <a:solidFill>
-                  <a:srgbClr val="FFFFFF"/>
+                  <a:srgbClr val="000000"/>
                 </a:solidFill>
                 <a:latin typeface="Arial"/>
               </a:rPr>
@@ -6293,7 +6293,7 @@
             <a:r>
               <a:rPr sz="1169" b="1">
                 <a:solidFill>
-                  <a:srgbClr val="FFFFFF"/>
+                  <a:srgbClr val="000000"/>
                 </a:solidFill>
                 <a:latin typeface="Arial"/>
               </a:rPr>
@@ -6347,7 +6347,7 @@
             <a:r>
               <a:rPr sz="1169" b="1">
                 <a:solidFill>
-                  <a:srgbClr val="FFFFFF"/>
+                  <a:srgbClr val="000000"/>
                 </a:solidFill>
                 <a:latin typeface="Arial"/>
               </a:rPr>
@@ -6401,7 +6401,7 @@
             <a:r>
               <a:rPr sz="1169" b="1">
                 <a:solidFill>
-                  <a:srgbClr val="FFFFFF"/>
+                  <a:srgbClr val="000000"/>
                 </a:solidFill>
                 <a:latin typeface="Arial"/>
               </a:rPr>
@@ -6560,7 +6560,7 @@
             <a:r>
               <a:rPr sz="1150" b="1">
                 <a:solidFill>
-                  <a:srgbClr val="FFFFFF"/>
+                  <a:srgbClr val="000000"/>
                 </a:solidFill>
                 <a:latin typeface="Arial"/>
               </a:rPr>
@@ -6595,7 +6595,7 @@
             <a:r>
               <a:rPr sz="1300" b="1">
                 <a:solidFill>
-                  <a:srgbClr val="FFFFFF"/>
+                  <a:srgbClr val="000000"/>
                 </a:solidFill>
                 <a:latin typeface="Arial"/>
               </a:rPr>
@@ -6630,7 +6630,7 @@
             <a:r>
               <a:rPr sz="950" b="1">
                 <a:solidFill>
-                  <a:srgbClr val="FFFFFF"/>
+                  <a:srgbClr val="000000"/>
                 </a:solidFill>
                 <a:latin typeface="Arial"/>
               </a:rPr>
@@ -6665,7 +6665,7 @@
             <a:r>
               <a:rPr sz="950" b="1">
                 <a:solidFill>
-                  <a:srgbClr val="FFFFFF"/>
+                  <a:srgbClr val="000000"/>
                 </a:solidFill>
                 <a:latin typeface="Arial"/>
               </a:rPr>
@@ -6700,7 +6700,7 @@
             <a:r>
               <a:rPr sz="950" b="1">
                 <a:solidFill>
-                  <a:srgbClr val="FFFFFF"/>
+                  <a:srgbClr val="000000"/>
                 </a:solidFill>
                 <a:latin typeface="Arial"/>
               </a:rPr>
@@ -6735,7 +6735,7 @@
             <a:r>
               <a:rPr sz="950" b="1">
                 <a:solidFill>
-                  <a:srgbClr val="FFFFFF"/>
+                  <a:srgbClr val="000000"/>
                 </a:solidFill>
                 <a:latin typeface="Arial"/>
               </a:rPr>
@@ -6770,7 +6770,7 @@
             <a:r>
               <a:rPr sz="950" b="1">
                 <a:solidFill>
-                  <a:srgbClr val="FFFFFF"/>
+                  <a:srgbClr val="000000"/>
                 </a:solidFill>
                 <a:latin typeface="Arial"/>
               </a:rPr>
@@ -6805,7 +6805,7 @@
             <a:r>
               <a:rPr sz="950" b="1">
                 <a:solidFill>
-                  <a:srgbClr val="FFFFFF"/>
+                  <a:srgbClr val="000000"/>
                 </a:solidFill>
                 <a:latin typeface="Arial"/>
               </a:rPr>
@@ -6859,7 +6859,7 @@
             <a:r>
               <a:rPr sz="950" b="1">
                 <a:solidFill>
-                  <a:srgbClr val="FFFFFF"/>
+                  <a:srgbClr val="000000"/>
                 </a:solidFill>
                 <a:latin typeface="Arial"/>
               </a:rPr>
@@ -6913,7 +6913,7 @@
             <a:r>
               <a:rPr sz="950" b="1">
                 <a:solidFill>
-                  <a:srgbClr val="FFFFFF"/>
+                  <a:srgbClr val="000000"/>
                 </a:solidFill>
                 <a:latin typeface="Arial"/>
               </a:rPr>
@@ -6967,7 +6967,7 @@
             <a:r>
               <a:rPr sz="950" b="1">
                 <a:solidFill>
-                  <a:srgbClr val="FFFFFF"/>
+                  <a:srgbClr val="000000"/>
                 </a:solidFill>
                 <a:latin typeface="Arial"/>
               </a:rPr>
@@ -7107,7 +7107,7 @@
             <a:r>
               <a:rPr sz="1300" b="1">
                 <a:solidFill>
-                  <a:srgbClr val="FFFFFF"/>
+                  <a:srgbClr val="000000"/>
                 </a:solidFill>
                 <a:latin typeface="Arial"/>
               </a:rPr>
@@ -7161,7 +7161,7 @@
             <a:r>
               <a:rPr sz="950" b="1">
                 <a:solidFill>
-                  <a:srgbClr val="FFFFFF"/>
+                  <a:srgbClr val="000000"/>
                 </a:solidFill>
                 <a:latin typeface="Arial"/>
               </a:rPr>
@@ -7196,7 +7196,7 @@
             <a:r>
               <a:rPr sz="950" b="1">
                 <a:solidFill>
-                  <a:srgbClr val="FFFFFF"/>
+                  <a:srgbClr val="000000"/>
                 </a:solidFill>
                 <a:latin typeface="Arial"/>
               </a:rPr>
@@ -7285,7 +7285,7 @@
             <a:r>
               <a:rPr sz="950" b="1">
                 <a:solidFill>
-                  <a:srgbClr val="FFFFFF"/>
+                  <a:srgbClr val="000000"/>
                 </a:solidFill>
                 <a:latin typeface="Arial"/>
               </a:rPr>
@@ -7320,7 +7320,7 @@
             <a:r>
               <a:rPr sz="950" b="1">
                 <a:solidFill>
-                  <a:srgbClr val="FFFFFF"/>
+                  <a:srgbClr val="000000"/>
                 </a:solidFill>
                 <a:latin typeface="Arial"/>
               </a:rPr>
@@ -7409,7 +7409,7 @@
             <a:r>
               <a:rPr sz="950" b="1">
                 <a:solidFill>
-                  <a:srgbClr val="FFFFFF"/>
+                  <a:srgbClr val="000000"/>
                 </a:solidFill>
                 <a:latin typeface="Arial"/>
               </a:rPr>
@@ -7444,7 +7444,7 @@
             <a:r>
               <a:rPr sz="950" b="1">
                 <a:solidFill>
-                  <a:srgbClr val="FFFFFF"/>
+                  <a:srgbClr val="000000"/>
                 </a:solidFill>
                 <a:latin typeface="Arial"/>
               </a:rPr>
@@ -7533,7 +7533,7 @@
             <a:r>
               <a:rPr sz="950" b="1">
                 <a:solidFill>
-                  <a:srgbClr val="FFFFFF"/>
+                  <a:srgbClr val="000000"/>
                 </a:solidFill>
                 <a:latin typeface="Arial"/>
               </a:rPr>
@@ -7568,7 +7568,7 @@
             <a:r>
               <a:rPr sz="950" b="1">
                 <a:solidFill>
-                  <a:srgbClr val="FFFFFF"/>
+                  <a:srgbClr val="000000"/>
                 </a:solidFill>
                 <a:latin typeface="Arial"/>
               </a:rPr>
@@ -7657,7 +7657,7 @@
             <a:r>
               <a:rPr sz="950" b="1">
                 <a:solidFill>
-                  <a:srgbClr val="FFFFFF"/>
+                  <a:srgbClr val="000000"/>
                 </a:solidFill>
                 <a:latin typeface="Arial"/>
               </a:rPr>
@@ -7692,7 +7692,7 @@
             <a:r>
               <a:rPr sz="950" b="1">
                 <a:solidFill>
-                  <a:srgbClr val="FFFFFF"/>
+                  <a:srgbClr val="000000"/>
                 </a:solidFill>
                 <a:latin typeface="Arial"/>
               </a:rPr>
@@ -7746,7 +7746,7 @@
             <a:r>
               <a:rPr sz="950" b="1">
                 <a:solidFill>
-                  <a:srgbClr val="FFFFFF"/>
+                  <a:srgbClr val="000000"/>
                 </a:solidFill>
                 <a:latin typeface="Arial"/>
               </a:rPr>
@@ -7781,7 +7781,7 @@
             <a:r>
               <a:rPr sz="950" b="1">
                 <a:solidFill>
-                  <a:srgbClr val="FFFFFF"/>
+                  <a:srgbClr val="000000"/>
                 </a:solidFill>
                 <a:latin typeface="Arial"/>
               </a:rPr>
@@ -7870,7 +7870,7 @@
             <a:r>
               <a:rPr sz="950" b="1">
                 <a:solidFill>
-                  <a:srgbClr val="FFFFFF"/>
+                  <a:srgbClr val="000000"/>
                 </a:solidFill>
                 <a:latin typeface="Arial"/>
               </a:rPr>
@@ -7905,7 +7905,7 @@
             <a:r>
               <a:rPr sz="950" b="1">
                 <a:solidFill>
-                  <a:srgbClr val="FFFFFF"/>
+                  <a:srgbClr val="000000"/>
                 </a:solidFill>
                 <a:latin typeface="Arial"/>
               </a:rPr>
@@ -7994,7 +7994,7 @@
             <a:r>
               <a:rPr sz="950" b="1">
                 <a:solidFill>
-                  <a:srgbClr val="FFFFFF"/>
+                  <a:srgbClr val="000000"/>
                 </a:solidFill>
                 <a:latin typeface="Arial"/>
               </a:rPr>
@@ -8029,7 +8029,7 @@
             <a:r>
               <a:rPr sz="950" b="1">
                 <a:solidFill>
-                  <a:srgbClr val="FFFFFF"/>
+                  <a:srgbClr val="000000"/>
                 </a:solidFill>
                 <a:latin typeface="Arial"/>
               </a:rPr>
@@ -8118,7 +8118,7 @@
             <a:r>
               <a:rPr sz="950" b="1">
                 <a:solidFill>
-                  <a:srgbClr val="FFFFFF"/>
+                  <a:srgbClr val="000000"/>
                 </a:solidFill>
                 <a:latin typeface="Arial"/>
               </a:rPr>
@@ -8153,7 +8153,7 @@
             <a:r>
               <a:rPr sz="950" b="1">
                 <a:solidFill>
-                  <a:srgbClr val="FFFFFF"/>
+                  <a:srgbClr val="000000"/>
                 </a:solidFill>
                 <a:latin typeface="Arial"/>
               </a:rPr>
@@ -8223,7 +8223,7 @@
             <a:r>
               <a:rPr sz="950" b="1">
                 <a:solidFill>
-                  <a:srgbClr val="FFFFFF"/>
+                  <a:srgbClr val="000000"/>
                 </a:solidFill>
                 <a:latin typeface="Arial"/>
               </a:rPr>
@@ -8312,7 +8312,7 @@
             <a:r>
               <a:rPr sz="950" b="1">
                 <a:solidFill>
-                  <a:srgbClr val="FFFFFF"/>
+                  <a:srgbClr val="000000"/>
                 </a:solidFill>
                 <a:latin typeface="Arial"/>
               </a:rPr>
@@ -8404,7 +8404,7 @@
             <a:r>
               <a:rPr lang="en-US">
                 <a:solidFill>
-                  <a:schemeClr val="bg1"/>
+                  <a:srgbClr val="000000"/>
                 </a:solidFill>
               </a:rPr>
               <a:t>@SIH Idea submission- Template</a:t>
@@ -8473,7 +8473,7 @@
             <a:r>
               <a:rPr sz="2300" b="1">
                 <a:solidFill>
-                  <a:srgbClr val="FFFFFF"/>
+                  <a:srgbClr val="000000"/>
                 </a:solidFill>
                 <a:latin typeface="Arial"/>
               </a:rPr>
@@ -8508,7 +8508,7 @@
             <a:r>
               <a:rPr sz="1400" b="1">
                 <a:solidFill>
-                  <a:srgbClr val="FFFFFF"/>
+                  <a:srgbClr val="000000"/>
                 </a:solidFill>
                 <a:latin typeface="Arial"/>
               </a:rPr>
@@ -8562,7 +8562,7 @@
             <a:r>
               <a:rPr sz="1100" b="1">
                 <a:solidFill>
-                  <a:srgbClr val="FFFFFF"/>
+                  <a:srgbClr val="000000"/>
                 </a:solidFill>
                 <a:latin typeface="Arial"/>
               </a:rPr>
@@ -8616,7 +8616,7 @@
             <a:r>
               <a:rPr sz="950" b="1">
                 <a:solidFill>
-                  <a:srgbClr val="FFFFFF"/>
+                  <a:srgbClr val="000000"/>
                 </a:solidFill>
                 <a:latin typeface="Arial"/>
               </a:rPr>
@@ -8670,7 +8670,7 @@
             <a:r>
               <a:rPr sz="1100" b="1">
                 <a:solidFill>
-                  <a:srgbClr val="FFFFFF"/>
+                  <a:srgbClr val="000000"/>
                 </a:solidFill>
                 <a:latin typeface="Arial"/>
               </a:rPr>
@@ -8724,7 +8724,7 @@
             <a:r>
               <a:rPr sz="950" b="1">
                 <a:solidFill>
-                  <a:srgbClr val="FFFFFF"/>
+                  <a:srgbClr val="000000"/>
                 </a:solidFill>
                 <a:latin typeface="Arial"/>
               </a:rPr>
@@ -8778,7 +8778,7 @@
             <a:r>
               <a:rPr sz="1100" b="1">
                 <a:solidFill>
-                  <a:srgbClr val="FFFFFF"/>
+                  <a:srgbClr val="000000"/>
                 </a:solidFill>
                 <a:latin typeface="Arial"/>
               </a:rPr>
@@ -8832,7 +8832,7 @@
             <a:r>
               <a:rPr sz="950" b="1">
                 <a:solidFill>
-                  <a:srgbClr val="FFFFFF"/>
+                  <a:srgbClr val="000000"/>
                 </a:solidFill>
                 <a:latin typeface="Arial"/>
               </a:rPr>
@@ -8886,7 +8886,7 @@
             <a:r>
               <a:rPr sz="1100" b="1">
                 <a:solidFill>
-                  <a:srgbClr val="FFFFFF"/>
+                  <a:srgbClr val="000000"/>
                 </a:solidFill>
                 <a:latin typeface="Arial"/>
               </a:rPr>
@@ -8940,7 +8940,7 @@
             <a:r>
               <a:rPr sz="950" b="1">
                 <a:solidFill>
-                  <a:srgbClr val="FFFFFF"/>
+                  <a:srgbClr val="000000"/>
                 </a:solidFill>
                 <a:latin typeface="Arial"/>
               </a:rPr>
@@ -8994,7 +8994,7 @@
             <a:r>
               <a:rPr sz="1100" b="1">
                 <a:solidFill>
-                  <a:srgbClr val="FFFFFF"/>
+                  <a:srgbClr val="000000"/>
                 </a:solidFill>
                 <a:latin typeface="Arial"/>
               </a:rPr>
@@ -9048,7 +9048,7 @@
             <a:r>
               <a:rPr sz="950" b="1">
                 <a:solidFill>
-                  <a:srgbClr val="FFFFFF"/>
+                  <a:srgbClr val="000000"/>
                 </a:solidFill>
                 <a:latin typeface="Arial"/>
               </a:rPr>
@@ -9083,7 +9083,7 @@
             <a:r>
               <a:rPr sz="1400" b="1">
                 <a:solidFill>
-                  <a:srgbClr val="FFFFFF"/>
+                  <a:srgbClr val="000000"/>
                 </a:solidFill>
                 <a:latin typeface="Arial"/>
               </a:rPr>
@@ -9137,7 +9137,7 @@
             <a:r>
               <a:rPr sz="1100" b="1">
                 <a:solidFill>
-                  <a:srgbClr val="FFFFFF"/>
+                  <a:srgbClr val="000000"/>
                 </a:solidFill>
                 <a:latin typeface="Arial"/>
               </a:rPr>
@@ -9191,7 +9191,7 @@
             <a:r>
               <a:rPr sz="1100" b="1">
                 <a:solidFill>
-                  <a:srgbClr val="FFFFFF"/>
+                  <a:srgbClr val="000000"/>
                 </a:solidFill>
                 <a:latin typeface="Arial"/>
               </a:rPr>
@@ -9245,7 +9245,7 @@
             <a:r>
               <a:rPr sz="1100" b="1">
                 <a:solidFill>
-                  <a:srgbClr val="FFFFFF"/>
+                  <a:srgbClr val="000000"/>
                 </a:solidFill>
                 <a:latin typeface="Arial"/>
               </a:rPr>
@@ -9369,7 +9369,7 @@
             <a:r>
               <a:rPr sz="1150" b="1">
                 <a:solidFill>
-                  <a:srgbClr val="FFFFFF"/>
+                  <a:srgbClr val="000000"/>
                 </a:solidFill>
                 <a:latin typeface="Arial"/>
               </a:rPr>
@@ -9423,7 +9423,7 @@
             <a:r>
               <a:rPr sz="1150" b="1">
                 <a:solidFill>
-                  <a:srgbClr val="FFFFFF"/>
+                  <a:srgbClr val="000000"/>
                 </a:solidFill>
                 <a:latin typeface="Arial"/>
               </a:rPr>
@@ -9547,7 +9547,7 @@
             <a:r>
               <a:rPr sz="1100" b="1">
                 <a:solidFill>
-                  <a:srgbClr val="FFFFFF"/>
+                  <a:srgbClr val="000000"/>
                 </a:solidFill>
                 <a:latin typeface="Arial"/>
               </a:rPr>
@@ -9601,7 +9601,7 @@
             <a:r>
               <a:rPr sz="1100" b="1">
                 <a:solidFill>
-                  <a:srgbClr val="FFFFFF"/>
+                  <a:srgbClr val="000000"/>
                 </a:solidFill>
                 <a:latin typeface="Arial"/>
               </a:rPr>
@@ -9741,7 +9741,7 @@
             <a:r>
               <a:rPr sz="1300" b="1">
                 <a:solidFill>
-                  <a:srgbClr val="FFFFFF"/>
+                  <a:srgbClr val="000000"/>
                 </a:solidFill>
                 <a:latin typeface="Arial"/>
               </a:rPr>
@@ -9795,7 +9795,7 @@
             <a:r>
               <a:rPr sz="950" b="1">
                 <a:solidFill>
-                  <a:srgbClr val="FFFFFF"/>
+                  <a:srgbClr val="000000"/>
                 </a:solidFill>
                 <a:latin typeface="Arial"/>
               </a:rPr>
@@ -9885,7 +9885,7 @@
             <a:r>
               <a:rPr sz="950" b="1">
                 <a:solidFill>
-                  <a:srgbClr val="FFFFFF"/>
+                  <a:srgbClr val="000000"/>
                 </a:solidFill>
                 <a:latin typeface="Arial"/>
               </a:rPr>
@@ -9975,7 +9975,7 @@
             <a:r>
               <a:rPr sz="950" b="1">
                 <a:solidFill>
-                  <a:srgbClr val="FFFFFF"/>
+                  <a:srgbClr val="000000"/>
                 </a:solidFill>
                 <a:latin typeface="Arial"/>
               </a:rPr>
@@ -10065,7 +10065,7 @@
             <a:r>
               <a:rPr sz="950" b="1">
                 <a:solidFill>
-                  <a:srgbClr val="FFFFFF"/>
+                  <a:srgbClr val="000000"/>
                 </a:solidFill>
                 <a:latin typeface="Arial"/>
               </a:rPr>
@@ -10155,7 +10155,7 @@
             <a:r>
               <a:rPr sz="950" b="1">
                 <a:solidFill>
-                  <a:srgbClr val="FFFFFF"/>
+                  <a:srgbClr val="000000"/>
                 </a:solidFill>
                 <a:latin typeface="Arial"/>
               </a:rPr>
@@ -10245,7 +10245,7 @@
             <a:r>
               <a:rPr sz="950" b="1">
                 <a:solidFill>
-                  <a:srgbClr val="FFFFFF"/>
+                  <a:srgbClr val="000000"/>
                 </a:solidFill>
                 <a:latin typeface="Arial"/>
               </a:rPr>
@@ -10281,7 +10281,7 @@
             <a:r>
               <a:rPr sz="1069" b="1">
                 <a:solidFill>
-                  <a:srgbClr val="FFFFFF"/>
+                  <a:srgbClr val="000000"/>
                 </a:solidFill>
                 <a:latin typeface="Arial"/>
               </a:rPr>
@@ -10441,7 +10441,7 @@
                   <a:noFill/>
                 </a:ln>
                 <a:solidFill>
-                  <a:prstClr val="white"/>
+                  <a:srgbClr val="000000"/>
                 </a:solidFill>
                 <a:effectLst/>
                 <a:uLnTx/>
@@ -10525,7 +10525,7 @@
             <a:r>
               <a:rPr sz="2300" b="1">
                 <a:solidFill>
-                  <a:srgbClr val="FFFFFF"/>
+                  <a:srgbClr val="000000"/>
                 </a:solidFill>
                 <a:latin typeface="Arial"/>
               </a:rPr>
@@ -10560,7 +10560,7 @@
             <a:r>
               <a:rPr sz="1400" b="1">
                 <a:solidFill>
-                  <a:srgbClr val="FFFFFF"/>
+                  <a:srgbClr val="000000"/>
                 </a:solidFill>
                 <a:latin typeface="Arial"/>
               </a:rPr>
@@ -10614,7 +10614,7 @@
             <a:r>
               <a:rPr sz="950" b="1">
                 <a:solidFill>
-                  <a:srgbClr val="FFFFFF"/>
+                  <a:srgbClr val="000000"/>
                 </a:solidFill>
                 <a:latin typeface="Arial"/>
               </a:rPr>
@@ -10649,7 +10649,7 @@
             <a:r>
               <a:rPr sz="1100" b="1">
                 <a:solidFill>
-                  <a:srgbClr val="FFFFFF"/>
+                  <a:srgbClr val="000000"/>
                 </a:solidFill>
                 <a:latin typeface="Arial"/>
               </a:rPr>
@@ -10684,7 +10684,7 @@
             <a:r>
               <a:rPr sz="950" b="1">
                 <a:solidFill>
-                  <a:srgbClr val="FFFFFF"/>
+                  <a:srgbClr val="000000"/>
                 </a:solidFill>
                 <a:latin typeface="Arial"/>
               </a:rPr>
@@ -10738,7 +10738,7 @@
             <a:r>
               <a:rPr sz="950" b="1">
                 <a:solidFill>
-                  <a:srgbClr val="FFFFFF"/>
+                  <a:srgbClr val="000000"/>
                 </a:solidFill>
                 <a:latin typeface="Arial"/>
               </a:rPr>
@@ -10773,7 +10773,7 @@
             <a:r>
               <a:rPr sz="1100" b="1">
                 <a:solidFill>
-                  <a:srgbClr val="FFFFFF"/>
+                  <a:srgbClr val="000000"/>
                 </a:solidFill>
                 <a:latin typeface="Arial"/>
               </a:rPr>
@@ -10808,7 +10808,7 @@
             <a:r>
               <a:rPr sz="950" b="1">
                 <a:solidFill>
-                  <a:srgbClr val="FFFFFF"/>
+                  <a:srgbClr val="000000"/>
                 </a:solidFill>
                 <a:latin typeface="Arial"/>
               </a:rPr>
@@ -10862,7 +10862,7 @@
             <a:r>
               <a:rPr sz="950" b="1">
                 <a:solidFill>
-                  <a:srgbClr val="FFFFFF"/>
+                  <a:srgbClr val="000000"/>
                 </a:solidFill>
                 <a:latin typeface="Arial"/>
               </a:rPr>
@@ -10897,7 +10897,7 @@
             <a:r>
               <a:rPr sz="1100" b="1">
                 <a:solidFill>
-                  <a:srgbClr val="FFFFFF"/>
+                  <a:srgbClr val="000000"/>
                 </a:solidFill>
                 <a:latin typeface="Arial"/>
               </a:rPr>
@@ -10932,7 +10932,7 @@
             <a:r>
               <a:rPr sz="950" b="1">
                 <a:solidFill>
-                  <a:srgbClr val="FFFFFF"/>
+                  <a:srgbClr val="000000"/>
                 </a:solidFill>
                 <a:latin typeface="Arial"/>
               </a:rPr>
@@ -10986,7 +10986,7 @@
             <a:r>
               <a:rPr sz="950" b="1">
                 <a:solidFill>
-                  <a:srgbClr val="FFFFFF"/>
+                  <a:srgbClr val="000000"/>
                 </a:solidFill>
                 <a:latin typeface="Arial"/>
               </a:rPr>
@@ -11021,7 +11021,7 @@
             <a:r>
               <a:rPr sz="1100" b="1">
                 <a:solidFill>
-                  <a:srgbClr val="FFFFFF"/>
+                  <a:srgbClr val="000000"/>
                 </a:solidFill>
                 <a:latin typeface="Arial"/>
               </a:rPr>
@@ -11056,7 +11056,7 @@
             <a:r>
               <a:rPr sz="950" b="1">
                 <a:solidFill>
-                  <a:srgbClr val="FFFFFF"/>
+                  <a:srgbClr val="000000"/>
                 </a:solidFill>
                 <a:latin typeface="Arial"/>
               </a:rPr>
@@ -11091,7 +11091,7 @@
             <a:r>
               <a:rPr sz="1400" b="1">
                 <a:solidFill>
-                  <a:srgbClr val="FFFFFF"/>
+                  <a:srgbClr val="000000"/>
                 </a:solidFill>
                 <a:latin typeface="Arial"/>
               </a:rPr>
@@ -11145,7 +11145,7 @@
             <a:r>
               <a:rPr sz="1050" b="1">
                 <a:solidFill>
-                  <a:srgbClr val="FFFFFF"/>
+                  <a:srgbClr val="000000"/>
                 </a:solidFill>
                 <a:latin typeface="Arial"/>
               </a:rPr>
@@ -11180,7 +11180,7 @@
             <a:r>
               <a:rPr sz="950" b="1">
                 <a:solidFill>
-                  <a:srgbClr val="FFFFFF"/>
+                  <a:srgbClr val="000000"/>
                 </a:solidFill>
                 <a:latin typeface="Arial"/>
               </a:rPr>
@@ -11234,7 +11234,7 @@
             <a:r>
               <a:rPr sz="1050" b="1">
                 <a:solidFill>
-                  <a:srgbClr val="FFFFFF"/>
+                  <a:srgbClr val="000000"/>
                 </a:solidFill>
                 <a:latin typeface="Arial"/>
               </a:rPr>
@@ -11269,7 +11269,7 @@
             <a:r>
               <a:rPr sz="950" b="1">
                 <a:solidFill>
-                  <a:srgbClr val="FFFFFF"/>
+                  <a:srgbClr val="000000"/>
                 </a:solidFill>
                 <a:latin typeface="Arial"/>
               </a:rPr>
@@ -11323,7 +11323,7 @@
             <a:r>
               <a:rPr sz="1050" b="1">
                 <a:solidFill>
-                  <a:srgbClr val="FFFFFF"/>
+                  <a:srgbClr val="000000"/>
                 </a:solidFill>
                 <a:latin typeface="Arial"/>
               </a:rPr>
@@ -11358,7 +11358,7 @@
             <a:r>
               <a:rPr sz="950" b="1">
                 <a:solidFill>
-                  <a:srgbClr val="FFFFFF"/>
+                  <a:srgbClr val="000000"/>
                 </a:solidFill>
                 <a:latin typeface="Arial"/>
               </a:rPr>
@@ -11412,7 +11412,7 @@
             <a:r>
               <a:rPr sz="1050" b="1">
                 <a:solidFill>
-                  <a:srgbClr val="FFFFFF"/>
+                  <a:srgbClr val="000000"/>
                 </a:solidFill>
                 <a:latin typeface="Arial"/>
               </a:rPr>
@@ -11447,7 +11447,7 @@
             <a:r>
               <a:rPr sz="950" b="1">
                 <a:solidFill>
-                  <a:srgbClr val="FFFFFF"/>
+                  <a:srgbClr val="000000"/>
                 </a:solidFill>
                 <a:latin typeface="Arial"/>
               </a:rPr>
@@ -11482,7 +11482,7 @@
             <a:r>
               <a:rPr sz="1400" b="1">
                 <a:solidFill>
-                  <a:srgbClr val="FFFFFF"/>
+                  <a:srgbClr val="000000"/>
                 </a:solidFill>
                 <a:latin typeface="Arial"/>
               </a:rPr>
@@ -11536,7 +11536,7 @@
             <a:r>
               <a:rPr sz="950" b="1">
                 <a:solidFill>
-                  <a:srgbClr val="FFFFFF"/>
+                  <a:srgbClr val="000000"/>
                 </a:solidFill>
                 <a:latin typeface="Arial"/>
               </a:rPr>
@@ -11571,7 +11571,7 @@
             <a:r>
               <a:rPr sz="950" b="1">
                 <a:solidFill>
-                  <a:srgbClr val="FFFFFF"/>
+                  <a:srgbClr val="000000"/>
                 </a:solidFill>
                 <a:latin typeface="Arial"/>
               </a:rPr>
@@ -11625,7 +11625,7 @@
             <a:r>
               <a:rPr sz="950" b="1">
                 <a:solidFill>
-                  <a:srgbClr val="FFFFFF"/>
+                  <a:srgbClr val="000000"/>
                 </a:solidFill>
                 <a:latin typeface="Arial"/>
               </a:rPr>
@@ -11660,7 +11660,7 @@
             <a:r>
               <a:rPr sz="950" b="1">
                 <a:solidFill>
-                  <a:srgbClr val="FFFFFF"/>
+                  <a:srgbClr val="000000"/>
                 </a:solidFill>
                 <a:latin typeface="Arial"/>
               </a:rPr>
@@ -11714,7 +11714,7 @@
             <a:r>
               <a:rPr sz="950" b="1">
                 <a:solidFill>
-                  <a:srgbClr val="FFFFFF"/>
+                  <a:srgbClr val="000000"/>
                 </a:solidFill>
                 <a:latin typeface="Arial"/>
               </a:rPr>
@@ -11749,7 +11749,7 @@
             <a:r>
               <a:rPr sz="950" b="1">
                 <a:solidFill>
-                  <a:srgbClr val="FFFFFF"/>
+                  <a:srgbClr val="000000"/>
                 </a:solidFill>
                 <a:latin typeface="Arial"/>
               </a:rPr>
@@ -11803,7 +11803,7 @@
             <a:r>
               <a:rPr sz="950" b="1">
                 <a:solidFill>
-                  <a:srgbClr val="FFFFFF"/>
+                  <a:srgbClr val="000000"/>
                 </a:solidFill>
                 <a:latin typeface="Arial"/>
               </a:rPr>
@@ -11838,7 +11838,7 @@
             <a:r>
               <a:rPr sz="950" b="1">
                 <a:solidFill>
-                  <a:srgbClr val="FFFFFF"/>
+                  <a:srgbClr val="000000"/>
                 </a:solidFill>
                 <a:latin typeface="Arial"/>
               </a:rPr>
@@ -11873,7 +11873,7 @@
             <a:r>
               <a:rPr sz="1350" b="1">
                 <a:solidFill>
-                  <a:srgbClr val="FFFFFF"/>
+                  <a:srgbClr val="000000"/>
                 </a:solidFill>
                 <a:latin typeface="Arial"/>
               </a:rPr>
@@ -11927,7 +11927,7 @@
             <a:r>
               <a:rPr sz="950" b="1">
                 <a:solidFill>
-                  <a:srgbClr val="FFFFFF"/>
+                  <a:srgbClr val="000000"/>
                 </a:solidFill>
                 <a:latin typeface="Arial"/>
               </a:rPr>
@@ -12016,7 +12016,7 @@
             <a:r>
               <a:rPr sz="950" b="1">
                 <a:solidFill>
-                  <a:srgbClr val="FFFFFF"/>
+                  <a:srgbClr val="000000"/>
                 </a:solidFill>
                 <a:latin typeface="Arial"/>
               </a:rPr>
@@ -12070,7 +12070,7 @@
             <a:r>
               <a:rPr sz="950" b="1">
                 <a:solidFill>
-                  <a:srgbClr val="FFFFFF"/>
+                  <a:srgbClr val="000000"/>
                 </a:solidFill>
                 <a:latin typeface="Arial"/>
               </a:rPr>
@@ -12159,7 +12159,7 @@
             <a:r>
               <a:rPr sz="950" b="1">
                 <a:solidFill>
-                  <a:srgbClr val="FFFFFF"/>
+                  <a:srgbClr val="000000"/>
                 </a:solidFill>
                 <a:latin typeface="Arial"/>
               </a:rPr>
@@ -12213,7 +12213,7 @@
             <a:r>
               <a:rPr sz="950" b="1">
                 <a:solidFill>
-                  <a:srgbClr val="FFFFFF"/>
+                  <a:srgbClr val="000000"/>
                 </a:solidFill>
                 <a:latin typeface="Arial"/>
               </a:rPr>
@@ -12302,7 +12302,7 @@
             <a:r>
               <a:rPr sz="950" b="1">
                 <a:solidFill>
-                  <a:srgbClr val="FFFFFF"/>
+                  <a:srgbClr val="000000"/>
                 </a:solidFill>
                 <a:latin typeface="Arial"/>
               </a:rPr>
@@ -12356,7 +12356,7 @@
             <a:r>
               <a:rPr sz="950" b="1">
                 <a:solidFill>
-                  <a:srgbClr val="FFFFFF"/>
+                  <a:srgbClr val="000000"/>
                 </a:solidFill>
                 <a:latin typeface="Arial"/>
               </a:rPr>
@@ -12445,7 +12445,7 @@
             <a:r>
               <a:rPr sz="950" b="1">
                 <a:solidFill>
-                  <a:srgbClr val="FFFFFF"/>
+                  <a:srgbClr val="000000"/>
                 </a:solidFill>
                 <a:latin typeface="Arial"/>
               </a:rPr>
@@ -12480,7 +12480,7 @@
             <a:r>
               <a:rPr sz="1100" b="1">
                 <a:solidFill>
-                  <a:srgbClr val="FFFFFF"/>
+                  <a:srgbClr val="000000"/>
                 </a:solidFill>
                 <a:latin typeface="Arial"/>
               </a:rPr>
@@ -12645,7 +12645,7 @@
                   <a:noFill/>
                 </a:ln>
                 <a:solidFill>
-                  <a:prstClr val="white"/>
+                  <a:srgbClr val="000000"/>
                 </a:solidFill>
                 <a:effectLst/>
                 <a:uLnTx/>
@@ -12729,7 +12729,7 @@
             <a:r>
               <a:rPr sz="2300" b="1">
                 <a:solidFill>
-                  <a:srgbClr val="FFFFFF"/>
+                  <a:srgbClr val="000000"/>
                 </a:solidFill>
                 <a:latin typeface="Arial"/>
               </a:rPr>
@@ -12764,7 +12764,7 @@
             <a:r>
               <a:rPr sz="1350" b="1">
                 <a:solidFill>
-                  <a:srgbClr val="FFFFFF"/>
+                  <a:srgbClr val="000000"/>
                 </a:solidFill>
                 <a:latin typeface="Arial"/>
               </a:rPr>
@@ -12799,7 +12799,7 @@
             <a:r>
               <a:rPr sz="950" b="1">
                 <a:solidFill>
-                  <a:srgbClr val="FFFFFF"/>
+                  <a:srgbClr val="000000"/>
                 </a:solidFill>
                 <a:latin typeface="Arial"/>
               </a:rPr>
@@ -12920,7 +12920,7 @@
             <a:r>
               <a:rPr sz="950" b="1">
                 <a:solidFill>
-                  <a:srgbClr val="FFFFFF"/>
+                  <a:srgbClr val="000000"/>
                 </a:solidFill>
                 <a:latin typeface="Arial"/>
               </a:rPr>
@@ -13041,7 +13041,7 @@
             <a:r>
               <a:rPr sz="950" b="1">
                 <a:solidFill>
-                  <a:srgbClr val="FFFFFF"/>
+                  <a:srgbClr val="000000"/>
                 </a:solidFill>
                 <a:latin typeface="Arial"/>
               </a:rPr>
@@ -13162,7 +13162,7 @@
             <a:r>
               <a:rPr sz="950" b="1">
                 <a:solidFill>
-                  <a:srgbClr val="FFFFFF"/>
+                  <a:srgbClr val="000000"/>
                 </a:solidFill>
                 <a:latin typeface="Arial"/>
               </a:rPr>
@@ -13283,7 +13283,7 @@
             <a:r>
               <a:rPr sz="1350" b="1">
                 <a:solidFill>
-                  <a:srgbClr val="FFFFFF"/>
+                  <a:srgbClr val="000000"/>
                 </a:solidFill>
                 <a:latin typeface="Arial"/>
               </a:rPr>
@@ -13337,7 +13337,7 @@
             <a:r>
               <a:rPr sz="950" b="1">
                 <a:solidFill>
-                  <a:srgbClr val="FFFFFF"/>
+                  <a:srgbClr val="000000"/>
                 </a:solidFill>
                 <a:latin typeface="Arial"/>
               </a:rPr>
@@ -13391,7 +13391,7 @@
             <a:r>
               <a:rPr sz="950" b="1">
                 <a:solidFill>
-                  <a:srgbClr val="FFFFFF"/>
+                  <a:srgbClr val="000000"/>
                 </a:solidFill>
                 <a:latin typeface="Arial"/>
               </a:rPr>
@@ -13445,7 +13445,7 @@
             <a:r>
               <a:rPr sz="950" b="1">
                 <a:solidFill>
-                  <a:srgbClr val="FFFFFF"/>
+                  <a:srgbClr val="000000"/>
                 </a:solidFill>
                 <a:latin typeface="Arial"/>
               </a:rPr>
@@ -13499,7 +13499,7 @@
             <a:r>
               <a:rPr sz="950" b="1">
                 <a:solidFill>
-                  <a:srgbClr val="FFFFFF"/>
+                  <a:srgbClr val="000000"/>
                 </a:solidFill>
                 <a:latin typeface="Arial"/>
               </a:rPr>
@@ -13553,7 +13553,7 @@
             <a:r>
               <a:rPr sz="950" b="1">
                 <a:solidFill>
-                  <a:srgbClr val="FFFFFF"/>
+                  <a:srgbClr val="000000"/>
                 </a:solidFill>
                 <a:latin typeface="Arial"/>
               </a:rPr>
@@ -13588,7 +13588,7 @@
             <a:r>
               <a:rPr sz="1350" b="1">
                 <a:solidFill>
-                  <a:srgbClr val="FFFFFF"/>
+                  <a:srgbClr val="000000"/>
                 </a:solidFill>
                 <a:latin typeface="Arial"/>
               </a:rPr>
@@ -13642,7 +13642,7 @@
             <a:r>
               <a:rPr sz="950" b="1">
                 <a:solidFill>
-                  <a:srgbClr val="FFFFFF"/>
+                  <a:srgbClr val="000000"/>
                 </a:solidFill>
                 <a:latin typeface="Arial"/>
               </a:rPr>
@@ -13677,7 +13677,7 @@
             <a:r>
               <a:rPr sz="950" b="1">
                 <a:solidFill>
-                  <a:srgbClr val="FFFFFF"/>
+                  <a:srgbClr val="000000"/>
                 </a:solidFill>
                 <a:latin typeface="Arial"/>
               </a:rPr>
@@ -13731,7 +13731,7 @@
             <a:r>
               <a:rPr sz="950" b="1">
                 <a:solidFill>
-                  <a:srgbClr val="FFFFFF"/>
+                  <a:srgbClr val="000000"/>
                 </a:solidFill>
                 <a:latin typeface="Arial"/>
               </a:rPr>
@@ -13766,7 +13766,7 @@
             <a:r>
               <a:rPr sz="950" b="1">
                 <a:solidFill>
-                  <a:srgbClr val="FFFFFF"/>
+                  <a:srgbClr val="000000"/>
                 </a:solidFill>
                 <a:latin typeface="Arial"/>
               </a:rPr>
@@ -13820,7 +13820,7 @@
             <a:r>
               <a:rPr sz="950" b="1">
                 <a:solidFill>
-                  <a:srgbClr val="FFFFFF"/>
+                  <a:srgbClr val="000000"/>
                 </a:solidFill>
                 <a:latin typeface="Arial"/>
               </a:rPr>
@@ -13855,7 +13855,7 @@
             <a:r>
               <a:rPr sz="950" b="1">
                 <a:solidFill>
-                  <a:srgbClr val="FFFFFF"/>
+                  <a:srgbClr val="000000"/>
                 </a:solidFill>
                 <a:latin typeface="Arial"/>
               </a:rPr>
@@ -13909,7 +13909,7 @@
             <a:r>
               <a:rPr sz="950" b="1">
                 <a:solidFill>
-                  <a:srgbClr val="FFFFFF"/>
+                  <a:srgbClr val="000000"/>
                 </a:solidFill>
                 <a:latin typeface="Arial"/>
               </a:rPr>
@@ -13942,7 +13942,9 @@
           <a:p>
             <a:r>
               <a:rPr sz="950" b="1">
-                <a:solidFill/>
+                <a:solidFill>
+                  <a:srgbClr val="000000"/>
+                </a:solidFill>
                 <a:latin typeface="Arial"/>
               </a:rPr>
               <a:t>AI-assisted personalization (Gemini) and continuous feedback (SkillEngine)</a:t>
@@ -13995,7 +13997,7 @@
             <a:r>
               <a:rPr sz="950" b="1">
                 <a:solidFill>
-                  <a:srgbClr val="FFFFFF"/>
+                  <a:srgbClr val="000000"/>
                 </a:solidFill>
                 <a:latin typeface="Arial"/>
               </a:rPr>
@@ -14030,7 +14032,7 @@
             <a:r>
               <a:rPr sz="950" b="1">
                 <a:solidFill>
-                  <a:srgbClr val="FFFFFF"/>
+                  <a:srgbClr val="000000"/>
                 </a:solidFill>
                 <a:latin typeface="Arial"/>
               </a:rPr>
@@ -14065,7 +14067,7 @@
             <a:r>
               <a:rPr sz="1250" b="1">
                 <a:solidFill>
-                  <a:srgbClr val="FFFFFF"/>
+                  <a:srgbClr val="000000"/>
                 </a:solidFill>
                 <a:latin typeface="Arial"/>
               </a:rPr>
@@ -14119,7 +14121,7 @@
             <a:r>
               <a:rPr sz="950" b="1">
                 <a:solidFill>
-                  <a:srgbClr val="FFFFFF"/>
+                  <a:srgbClr val="000000"/>
                 </a:solidFill>
                 <a:latin typeface="Arial"/>
               </a:rPr>
@@ -14209,7 +14211,7 @@
             <a:r>
               <a:rPr sz="950" b="1">
                 <a:solidFill>
-                  <a:srgbClr val="FFFFFF"/>
+                  <a:srgbClr val="000000"/>
                 </a:solidFill>
                 <a:latin typeface="Arial"/>
               </a:rPr>
@@ -14375,7 +14377,7 @@
                   <a:noFill/>
                 </a:ln>
                 <a:solidFill>
-                  <a:prstClr val="white"/>
+                  <a:srgbClr val="000000"/>
                 </a:solidFill>
                 <a:effectLst/>
                 <a:uLnTx/>
@@ -14459,7 +14461,7 @@
             <a:r>
               <a:rPr sz="2300" b="1">
                 <a:solidFill>
-                  <a:srgbClr val="FFFFFF"/>
+                  <a:srgbClr val="000000"/>
                 </a:solidFill>
                 <a:latin typeface="Arial"/>
               </a:rPr>
@@ -14494,7 +14496,7 @@
             <a:r>
               <a:rPr sz="1350" b="1">
                 <a:solidFill>
-                  <a:srgbClr val="FFFFFF"/>
+                  <a:srgbClr val="000000"/>
                 </a:solidFill>
                 <a:latin typeface="Arial"/>
               </a:rPr>
@@ -14548,7 +14550,7 @@
             <a:r>
               <a:rPr sz="950" b="1">
                 <a:solidFill>
-                  <a:srgbClr val="FFFFFF"/>
+                  <a:srgbClr val="000000"/>
                 </a:solidFill>
                 <a:latin typeface="Arial"/>
               </a:rPr>
@@ -14583,7 +14585,7 @@
             <a:r>
               <a:rPr sz="950" b="1">
                 <a:solidFill>
-                  <a:srgbClr val="FFFFFF"/>
+                  <a:srgbClr val="000000"/>
                 </a:solidFill>
                 <a:latin typeface="Arial"/>
               </a:rPr>
@@ -14618,7 +14620,7 @@
             <a:r>
               <a:rPr sz="950" b="1">
                 <a:solidFill>
-                  <a:srgbClr val="FFFFFF"/>
+                  <a:srgbClr val="000000"/>
                 </a:solidFill>
                 <a:latin typeface="Arial"/>
               </a:rPr>
@@ -14672,7 +14674,7 @@
             <a:r>
               <a:rPr sz="950" b="1">
                 <a:solidFill>
-                  <a:srgbClr val="FFFFFF"/>
+                  <a:srgbClr val="000000"/>
                 </a:solidFill>
                 <a:latin typeface="Arial"/>
               </a:rPr>
@@ -14707,7 +14709,7 @@
             <a:r>
               <a:rPr sz="950" b="1">
                 <a:solidFill>
-                  <a:srgbClr val="FFFFFF"/>
+                  <a:srgbClr val="000000"/>
                 </a:solidFill>
                 <a:latin typeface="Arial"/>
               </a:rPr>
@@ -14742,7 +14744,7 @@
             <a:r>
               <a:rPr sz="950" b="1">
                 <a:solidFill>
-                  <a:srgbClr val="FFFFFF"/>
+                  <a:srgbClr val="000000"/>
                 </a:solidFill>
                 <a:latin typeface="Arial"/>
               </a:rPr>
@@ -14796,7 +14798,7 @@
             <a:r>
               <a:rPr sz="950" b="1">
                 <a:solidFill>
-                  <a:srgbClr val="FFFFFF"/>
+                  <a:srgbClr val="000000"/>
                 </a:solidFill>
                 <a:latin typeface="Arial"/>
               </a:rPr>
@@ -14831,7 +14833,7 @@
             <a:r>
               <a:rPr sz="950" b="1">
                 <a:solidFill>
-                  <a:srgbClr val="FFFFFF"/>
+                  <a:srgbClr val="000000"/>
                 </a:solidFill>
                 <a:latin typeface="Arial"/>
               </a:rPr>
@@ -14866,7 +14868,7 @@
             <a:r>
               <a:rPr sz="950" b="1">
                 <a:solidFill>
-                  <a:srgbClr val="FFFFFF"/>
+                  <a:srgbClr val="000000"/>
                 </a:solidFill>
                 <a:latin typeface="Arial"/>
               </a:rPr>
@@ -14920,7 +14922,7 @@
             <a:r>
               <a:rPr sz="950" b="1">
                 <a:solidFill>
-                  <a:srgbClr val="FFFFFF"/>
+                  <a:srgbClr val="000000"/>
                 </a:solidFill>
                 <a:latin typeface="Arial"/>
               </a:rPr>
@@ -14955,7 +14957,7 @@
             <a:r>
               <a:rPr sz="950" b="1">
                 <a:solidFill>
-                  <a:srgbClr val="FFFFFF"/>
+                  <a:srgbClr val="000000"/>
                 </a:solidFill>
                 <a:latin typeface="Arial"/>
               </a:rPr>
@@ -14990,7 +14992,7 @@
             <a:r>
               <a:rPr sz="950" b="1">
                 <a:solidFill>
-                  <a:srgbClr val="FFFFFF"/>
+                  <a:srgbClr val="000000"/>
                 </a:solidFill>
                 <a:latin typeface="Arial"/>
               </a:rPr>
@@ -15025,7 +15027,7 @@
             <a:r>
               <a:rPr sz="1350" b="1">
                 <a:solidFill>
-                  <a:srgbClr val="FFFFFF"/>
+                  <a:srgbClr val="000000"/>
                 </a:solidFill>
                 <a:latin typeface="Arial"/>
               </a:rPr>
@@ -15079,7 +15081,7 @@
             <a:r>
               <a:rPr sz="950" b="1">
                 <a:solidFill>
-                  <a:srgbClr val="FFFFFF"/>
+                  <a:srgbClr val="000000"/>
                 </a:solidFill>
                 <a:latin typeface="Arial"/>
               </a:rPr>
@@ -15133,7 +15135,7 @@
             <a:r>
               <a:rPr sz="950" b="1">
                 <a:solidFill>
-                  <a:srgbClr val="FFFFFF"/>
+                  <a:srgbClr val="000000"/>
                 </a:solidFill>
                 <a:latin typeface="Arial"/>
               </a:rPr>
@@ -15187,7 +15189,7 @@
             <a:r>
               <a:rPr sz="950" b="1">
                 <a:solidFill>
-                  <a:srgbClr val="FFFFFF"/>
+                  <a:srgbClr val="000000"/>
                 </a:solidFill>
                 <a:latin typeface="Arial"/>
               </a:rPr>
@@ -15242,7 +15244,7 @@
             <a:r>
               <a:rPr sz="950" b="1">
                 <a:solidFill>
-                  <a:srgbClr val="FFFFFF"/>
+                  <a:srgbClr val="000000"/>
                 </a:solidFill>
                 <a:latin typeface="Arial"/>
               </a:rPr>
@@ -15296,7 +15298,7 @@
             <a:r>
               <a:rPr sz="950" b="1">
                 <a:solidFill>
-                  <a:srgbClr val="FFFFFF"/>
+                  <a:srgbClr val="000000"/>
                 </a:solidFill>
                 <a:latin typeface="Arial"/>
               </a:rPr>
@@ -15350,7 +15352,7 @@
             <a:r>
               <a:rPr sz="950" b="1">
                 <a:solidFill>
-                  <a:srgbClr val="FFFFFF"/>
+                  <a:srgbClr val="000000"/>
                 </a:solidFill>
                 <a:latin typeface="Arial"/>
               </a:rPr>
@@ -15404,7 +15406,7 @@
             <a:r>
               <a:rPr sz="950" b="1">
                 <a:solidFill>
-                  <a:srgbClr val="FFFFFF"/>
+                  <a:srgbClr val="000000"/>
                 </a:solidFill>
                 <a:latin typeface="Arial"/>
               </a:rPr>
@@ -15458,7 +15460,7 @@
             <a:r>
               <a:rPr sz="950" b="1">
                 <a:solidFill>
-                  <a:srgbClr val="FFFFFF"/>
+                  <a:srgbClr val="000000"/>
                 </a:solidFill>
                 <a:latin typeface="Arial"/>
               </a:rPr>
@@ -15512,7 +15514,7 @@
             <a:r>
               <a:rPr sz="950" b="1">
                 <a:solidFill>
-                  <a:srgbClr val="FFFFFF"/>
+                  <a:srgbClr val="000000"/>
                 </a:solidFill>
                 <a:latin typeface="Arial"/>
               </a:rPr>
@@ -15566,7 +15568,7 @@
             <a:r>
               <a:rPr sz="950" b="1">
                 <a:solidFill>
-                  <a:srgbClr val="FFFFFF"/>
+                  <a:srgbClr val="000000"/>
                 </a:solidFill>
                 <a:latin typeface="Arial"/>
               </a:rPr>
@@ -15620,7 +15622,7 @@
             <a:r>
               <a:rPr sz="950" b="1">
                 <a:solidFill>
-                  <a:srgbClr val="FFFFFF"/>
+                  <a:srgbClr val="000000"/>
                 </a:solidFill>
                 <a:latin typeface="Arial"/>
               </a:rPr>
@@ -15674,7 +15676,7 @@
             <a:r>
               <a:rPr sz="950" b="1">
                 <a:solidFill>
-                  <a:srgbClr val="FFFFFF"/>
+                  <a:srgbClr val="000000"/>
                 </a:solidFill>
                 <a:latin typeface="Arial"/>
               </a:rPr>
@@ -15728,7 +15730,7 @@
             <a:r>
               <a:rPr sz="950" b="1">
                 <a:solidFill>
-                  <a:srgbClr val="FFFFFF"/>
+                  <a:srgbClr val="000000"/>
                 </a:solidFill>
                 <a:latin typeface="Arial"/>
               </a:rPr>
@@ -15782,7 +15784,7 @@
             <a:r>
               <a:rPr sz="950" b="1">
                 <a:solidFill>
-                  <a:srgbClr val="FFFFFF"/>
+                  <a:srgbClr val="000000"/>
                 </a:solidFill>
                 <a:latin typeface="Arial"/>
               </a:rPr>
@@ -15836,7 +15838,7 @@
             <a:r>
               <a:rPr sz="950" b="1">
                 <a:solidFill>
-                  <a:srgbClr val="FFFFFF"/>
+                  <a:srgbClr val="000000"/>
                 </a:solidFill>
                 <a:latin typeface="Arial"/>
               </a:rPr>
@@ -15890,7 +15892,7 @@
             <a:r>
               <a:rPr sz="950" b="1">
                 <a:solidFill>
-                  <a:srgbClr val="FFFFFF"/>
+                  <a:srgbClr val="000000"/>
                 </a:solidFill>
                 <a:latin typeface="Arial"/>
               </a:rPr>
@@ -15944,7 +15946,7 @@
             <a:r>
               <a:rPr sz="950" b="1">
                 <a:solidFill>
-                  <a:srgbClr val="FFFFFF"/>
+                  <a:srgbClr val="000000"/>
                 </a:solidFill>
                 <a:latin typeface="Arial"/>
               </a:rPr>
@@ -15998,7 +16000,7 @@
             <a:r>
               <a:rPr sz="950" b="1">
                 <a:solidFill>
-                  <a:srgbClr val="FFFFFF"/>
+                  <a:srgbClr val="000000"/>
                 </a:solidFill>
                 <a:latin typeface="Arial"/>
               </a:rPr>
@@ -16052,7 +16054,7 @@
             <a:r>
               <a:rPr sz="950" b="1">
                 <a:solidFill>
-                  <a:srgbClr val="FFFFFF"/>
+                  <a:srgbClr val="000000"/>
                 </a:solidFill>
                 <a:latin typeface="Arial"/>
               </a:rPr>
@@ -16106,7 +16108,7 @@
             <a:r>
               <a:rPr sz="950" b="1">
                 <a:solidFill>
-                  <a:srgbClr val="FFFFFF"/>
+                  <a:srgbClr val="000000"/>
                 </a:solidFill>
                 <a:latin typeface="Arial"/>
               </a:rPr>
@@ -16160,7 +16162,7 @@
             <a:r>
               <a:rPr sz="950" b="1">
                 <a:solidFill>
-                  <a:srgbClr val="FFFFFF"/>
+                  <a:srgbClr val="000000"/>
                 </a:solidFill>
                 <a:latin typeface="Arial"/>
               </a:rPr>
@@ -16214,7 +16216,7 @@
             <a:r>
               <a:rPr sz="950" b="1">
                 <a:solidFill>
-                  <a:srgbClr val="FFFFFF"/>
+                  <a:srgbClr val="000000"/>
                 </a:solidFill>
                 <a:latin typeface="Arial"/>
               </a:rPr>
@@ -16268,7 +16270,7 @@
             <a:r>
               <a:rPr sz="950" b="1">
                 <a:solidFill>
-                  <a:srgbClr val="FFFFFF"/>
+                  <a:srgbClr val="000000"/>
                 </a:solidFill>
                 <a:latin typeface="Arial"/>
               </a:rPr>
@@ -16322,7 +16324,7 @@
             <a:r>
               <a:rPr sz="950" b="1">
                 <a:solidFill>
-                  <a:srgbClr val="FFFFFF"/>
+                  <a:srgbClr val="000000"/>
                 </a:solidFill>
                 <a:latin typeface="Arial"/>
               </a:rPr>
@@ -16376,7 +16378,7 @@
             <a:r>
               <a:rPr sz="950" b="1">
                 <a:solidFill>
-                  <a:srgbClr val="FFFFFF"/>
+                  <a:srgbClr val="000000"/>
                 </a:solidFill>
                 <a:latin typeface="Arial"/>
               </a:rPr>
@@ -16430,7 +16432,7 @@
             <a:r>
               <a:rPr sz="950" b="1">
                 <a:solidFill>
-                  <a:srgbClr val="FFFFFF"/>
+                  <a:srgbClr val="000000"/>
                 </a:solidFill>
                 <a:latin typeface="Arial"/>
               </a:rPr>
@@ -16484,7 +16486,7 @@
             <a:r>
               <a:rPr sz="950" b="1">
                 <a:solidFill>
-                  <a:srgbClr val="FFFFFF"/>
+                  <a:srgbClr val="000000"/>
                 </a:solidFill>
                 <a:latin typeface="Arial"/>
               </a:rPr>
@@ -16538,7 +16540,7 @@
             <a:r>
               <a:rPr sz="950" b="1">
                 <a:solidFill>
-                  <a:srgbClr val="FFFFFF"/>
+                  <a:srgbClr val="000000"/>
                 </a:solidFill>
                 <a:latin typeface="Arial"/>
               </a:rPr>
@@ -16592,7 +16594,7 @@
             <a:r>
               <a:rPr sz="950" b="1">
                 <a:solidFill>
-                  <a:srgbClr val="FFFFFF"/>
+                  <a:srgbClr val="000000"/>
                 </a:solidFill>
                 <a:latin typeface="Arial"/>
               </a:rPr>
@@ -16646,7 +16648,7 @@
             <a:r>
               <a:rPr sz="950" b="1">
                 <a:solidFill>
-                  <a:srgbClr val="FFFFFF"/>
+                  <a:srgbClr val="000000"/>
                 </a:solidFill>
                 <a:latin typeface="Arial"/>
               </a:rPr>
@@ -16700,7 +16702,7 @@
             <a:r>
               <a:rPr sz="950" b="1">
                 <a:solidFill>
-                  <a:srgbClr val="FFFFFF"/>
+                  <a:srgbClr val="000000"/>
                 </a:solidFill>
                 <a:latin typeface="Arial"/>
               </a:rPr>
@@ -16754,7 +16756,7 @@
             <a:r>
               <a:rPr sz="950" b="1">
                 <a:solidFill>
-                  <a:srgbClr val="FFFFFF"/>
+                  <a:srgbClr val="000000"/>
                 </a:solidFill>
                 <a:latin typeface="Arial"/>
               </a:rPr>
@@ -16808,7 +16810,7 @@
             <a:r>
               <a:rPr sz="950" b="1">
                 <a:solidFill>
-                  <a:srgbClr val="FFFFFF"/>
+                  <a:srgbClr val="000000"/>
                 </a:solidFill>
                 <a:latin typeface="Arial"/>
               </a:rPr>
@@ -16862,7 +16864,7 @@
             <a:r>
               <a:rPr sz="950" b="1">
                 <a:solidFill>
-                  <a:srgbClr val="FFFFFF"/>
+                  <a:srgbClr val="000000"/>
                 </a:solidFill>
                 <a:latin typeface="Arial"/>
               </a:rPr>
@@ -16916,7 +16918,7 @@
             <a:r>
               <a:rPr sz="950" b="1">
                 <a:solidFill>
-                  <a:srgbClr val="FFFFFF"/>
+                  <a:srgbClr val="000000"/>
                 </a:solidFill>
                 <a:latin typeface="Arial"/>
               </a:rPr>
@@ -16970,7 +16972,7 @@
             <a:r>
               <a:rPr sz="950" b="1">
                 <a:solidFill>
-                  <a:srgbClr val="FFFFFF"/>
+                  <a:srgbClr val="000000"/>
                 </a:solidFill>
                 <a:latin typeface="Arial"/>
               </a:rPr>
@@ -17024,7 +17026,7 @@
             <a:r>
               <a:rPr sz="950" b="1">
                 <a:solidFill>
-                  <a:srgbClr val="FFFFFF"/>
+                  <a:srgbClr val="000000"/>
                 </a:solidFill>
                 <a:latin typeface="Arial"/>
               </a:rPr>
@@ -17078,7 +17080,7 @@
             <a:r>
               <a:rPr sz="950" b="1">
                 <a:solidFill>
-                  <a:srgbClr val="FFFFFF"/>
+                  <a:srgbClr val="000000"/>
                 </a:solidFill>
                 <a:latin typeface="Arial"/>
               </a:rPr>
@@ -17132,7 +17134,7 @@
             <a:r>
               <a:rPr sz="950" b="1">
                 <a:solidFill>
-                  <a:srgbClr val="FFFFFF"/>
+                  <a:srgbClr val="000000"/>
                 </a:solidFill>
                 <a:latin typeface="Arial"/>
               </a:rPr>
@@ -17186,7 +17188,7 @@
             <a:r>
               <a:rPr sz="950" b="1">
                 <a:solidFill>
-                  <a:srgbClr val="FFFFFF"/>
+                  <a:srgbClr val="000000"/>
                 </a:solidFill>
                 <a:latin typeface="Arial"/>
               </a:rPr>
@@ -17240,7 +17242,7 @@
             <a:r>
               <a:rPr sz="950" b="1">
                 <a:solidFill>
-                  <a:srgbClr val="FFFFFF"/>
+                  <a:srgbClr val="000000"/>
                 </a:solidFill>
                 <a:latin typeface="Arial"/>
               </a:rPr>
@@ -17294,7 +17296,7 @@
             <a:r>
               <a:rPr sz="950" b="1">
                 <a:solidFill>
-                  <a:srgbClr val="FFFFFF"/>
+                  <a:srgbClr val="000000"/>
                 </a:solidFill>
                 <a:latin typeface="Arial"/>
               </a:rPr>
@@ -17348,7 +17350,7 @@
             <a:r>
               <a:rPr sz="950" b="1">
                 <a:solidFill>
-                  <a:srgbClr val="FFFFFF"/>
+                  <a:srgbClr val="000000"/>
                 </a:solidFill>
                 <a:latin typeface="Arial"/>
               </a:rPr>
@@ -17402,7 +17404,7 @@
             <a:r>
               <a:rPr sz="950" b="1">
                 <a:solidFill>
-                  <a:srgbClr val="FFFFFF"/>
+                  <a:srgbClr val="000000"/>
                 </a:solidFill>
                 <a:latin typeface="Arial"/>
               </a:rPr>
@@ -17456,7 +17458,7 @@
             <a:r>
               <a:rPr sz="950" b="1">
                 <a:solidFill>
-                  <a:srgbClr val="FFFFFF"/>
+                  <a:srgbClr val="000000"/>
                 </a:solidFill>
                 <a:latin typeface="Arial"/>
               </a:rPr>
@@ -17491,7 +17493,7 @@
             <a:r>
               <a:rPr sz="950" b="1">
                 <a:solidFill>
-                  <a:srgbClr val="FFFFFF"/>
+                  <a:srgbClr val="000000"/>
                 </a:solidFill>
                 <a:latin typeface="Arial"/>
               </a:rPr>
@@ -17526,7 +17528,7 @@
             <a:r>
               <a:rPr sz="950" b="1">
                 <a:solidFill>
-                  <a:srgbClr val="FFFFFF"/>
+                  <a:srgbClr val="000000"/>
                 </a:solidFill>
                 <a:latin typeface="Arial"/>
               </a:rPr>

</xml_diff>